<commit_message>
change of the charts in the presentation
</commit_message>
<xml_diff>
--- a/King County Housing Data Presentation.pptx
+++ b/King County Housing Data Presentation.pptx
@@ -9,16 +9,15 @@
     <p:sldId id="269" r:id="rId3"/>
     <p:sldId id="270" r:id="rId4"/>
     <p:sldId id="271" r:id="rId5"/>
-    <p:sldId id="273" r:id="rId6"/>
-    <p:sldId id="280" r:id="rId7"/>
-    <p:sldId id="272" r:id="rId8"/>
-    <p:sldId id="274" r:id="rId9"/>
-    <p:sldId id="276" r:id="rId10"/>
-    <p:sldId id="275" r:id="rId11"/>
-    <p:sldId id="277" r:id="rId12"/>
-    <p:sldId id="278" r:id="rId13"/>
-    <p:sldId id="279" r:id="rId14"/>
-    <p:sldId id="281" r:id="rId15"/>
+    <p:sldId id="280" r:id="rId6"/>
+    <p:sldId id="272" r:id="rId7"/>
+    <p:sldId id="274" r:id="rId8"/>
+    <p:sldId id="276" r:id="rId9"/>
+    <p:sldId id="275" r:id="rId10"/>
+    <p:sldId id="277" r:id="rId11"/>
+    <p:sldId id="278" r:id="rId12"/>
+    <p:sldId id="279" r:id="rId13"/>
+    <p:sldId id="281" r:id="rId14"/>
   </p:sldIdLst>
   <p:sldSz cx="12192000" cy="6858000"/>
   <p:notesSz cx="6858000" cy="9144000"/>
@@ -3540,10 +3539,10 @@
       </p:sp>
       <p:pic>
         <p:nvPicPr>
-          <p:cNvPr id="9" name="Inhaltsplatzhalter 8" descr="Ein Bild, das Text, Screenshot, Quadrat, Muster enthält.&#10;&#10;KI-generierte Inhalte können fehlerhaft sein.">
-            <a:extLst>
-              <a:ext uri="{FF2B5EF4-FFF2-40B4-BE49-F238E27FC236}">
-                <a16:creationId xmlns:a16="http://schemas.microsoft.com/office/drawing/2014/main" id="{4C95F22F-7052-8C26-9FA7-B9493CF3C974}"/>
+          <p:cNvPr id="13" name="Inhaltsplatzhalter 12" descr="Ein Bild, das Text, Screenshot, Schrift, Reihe enthält.&#10;&#10;KI-generierte Inhalte können fehlerhaft sein.">
+            <a:extLst>
+              <a:ext uri="{FF2B5EF4-FFF2-40B4-BE49-F238E27FC236}">
+                <a16:creationId xmlns:a16="http://schemas.microsoft.com/office/drawing/2014/main" id="{FFD3F0D4-0528-5FF7-96F5-47A166B0EF81}"/>
               </a:ext>
             </a:extLst>
           </p:cNvPr>
@@ -3568,15 +3567,15 @@
         </p:blipFill>
         <p:spPr>
           <a:xfrm>
-            <a:off x="1022104" y="2505075"/>
-            <a:ext cx="4793154" cy="3684588"/>
+            <a:off x="839788" y="2505075"/>
+            <a:ext cx="7405854" cy="3684588"/>
           </a:xfrm>
         </p:spPr>
       </p:pic>
     </p:spTree>
     <p:extLst>
       <p:ext uri="{BB962C8B-B14F-4D97-AF65-F5344CB8AC3E}">
-        <p14:creationId xmlns:p14="http://schemas.microsoft.com/office/powerpoint/2010/main" val="327037832"/>
+        <p14:creationId xmlns:p14="http://schemas.microsoft.com/office/powerpoint/2010/main" val="2951297496"/>
       </p:ext>
     </p:extLst>
   </p:cSld>
@@ -3654,16 +3653,18 @@
           </a:xfrm>
         </p:spPr>
         <p:txBody>
-          <a:bodyPr/>
-          <a:lstStyle/>
-          <a:p>
-            <a:r>
-              <a:rPr lang="de-DE" dirty="0"/>
-              <a:t>Hypothesis 2: </a:t>
+          <a:bodyPr anchor="t">
+            <a:normAutofit/>
+          </a:bodyPr>
+          <a:lstStyle/>
+          <a:p>
+            <a:r>
+              <a:rPr lang="de-DE" dirty="0"/>
+              <a:t>Hypothesis 3: </a:t>
             </a:r>
             <a:r>
               <a:rPr lang="en-US" dirty="0"/>
-              <a:t>There is at least one variable which has a bigger impact on the price than the others.</a:t>
+              <a:t>The price for a house is lower in the first half of a year</a:t>
             </a:r>
           </a:p>
         </p:txBody>
@@ -3700,10 +3701,10 @@
       </p:sp>
       <p:pic>
         <p:nvPicPr>
-          <p:cNvPr id="8" name="Inhaltsplatzhalter 7" descr="Ein Bild, das Text, Diagramm, Screenshot, Reihe enthält.&#10;&#10;KI-generierte Inhalte können fehlerhaft sein.">
-            <a:extLst>
-              <a:ext uri="{FF2B5EF4-FFF2-40B4-BE49-F238E27FC236}">
-                <a16:creationId xmlns:a16="http://schemas.microsoft.com/office/drawing/2014/main" id="{775C9A6D-04F4-9346-4FCB-90B99153C5C7}"/>
+          <p:cNvPr id="13" name="Inhaltsplatzhalter 12" descr="Ein Bild, das Text, Screenshot, Reihe, Diagramm enthält.&#10;&#10;KI-generierte Inhalte können fehlerhaft sein.">
+            <a:extLst>
+              <a:ext uri="{FF2B5EF4-FFF2-40B4-BE49-F238E27FC236}">
+                <a16:creationId xmlns:a16="http://schemas.microsoft.com/office/drawing/2014/main" id="{BE1FDE1C-7042-9057-F978-5A80753B9E49}"/>
               </a:ext>
             </a:extLst>
           </p:cNvPr>
@@ -3728,15 +3729,15 @@
         </p:blipFill>
         <p:spPr>
           <a:xfrm>
-            <a:off x="918424" y="2505075"/>
-            <a:ext cx="7279091" cy="3684588"/>
+            <a:off x="836612" y="2454442"/>
+            <a:ext cx="7043521" cy="3911684"/>
           </a:xfrm>
         </p:spPr>
       </p:pic>
     </p:spTree>
     <p:extLst>
       <p:ext uri="{BB962C8B-B14F-4D97-AF65-F5344CB8AC3E}">
-        <p14:creationId xmlns:p14="http://schemas.microsoft.com/office/powerpoint/2010/main" val="2951297496"/>
+        <p14:creationId xmlns:p14="http://schemas.microsoft.com/office/powerpoint/2010/main" val="2464344804"/>
       </p:ext>
     </p:extLst>
   </p:cSld>
@@ -3785,9 +3786,10 @@
           <a:lstStyle/>
           <a:p>
             <a:r>
-              <a:rPr lang="de-DE" dirty="0"/>
-              <a:t>Hypothesis</a:t>
-            </a:r>
+              <a:rPr lang="de-DE" dirty="0" err="1"/>
+              <a:t>Recommendation</a:t>
+            </a:r>
+            <a:endParaRPr lang="de-DE" dirty="0"/>
           </a:p>
         </p:txBody>
       </p:sp>
@@ -3848,7 +3850,7 @@
         </p:nvSpPr>
         <p:spPr>
           <a:xfrm>
-            <a:off x="8582526" y="2505075"/>
+            <a:off x="8579350" y="2491539"/>
             <a:ext cx="2772862" cy="3684588"/>
           </a:xfrm>
         </p:spPr>
@@ -3856,16 +3858,22 @@
           <a:bodyPr/>
           <a:lstStyle/>
           <a:p>
+            <a:r>
+              <a:rPr lang="en-US" sz="2400" dirty="0"/>
+              <a:t>98188 is the cheapest zip code in Seattle</a:t>
+            </a:r>
+          </a:p>
+          <a:p>
             <a:endParaRPr lang="de-DE" dirty="0"/>
           </a:p>
         </p:txBody>
       </p:sp>
       <p:pic>
         <p:nvPicPr>
-          <p:cNvPr id="9" name="Inhaltsplatzhalter 8" descr="Ein Bild, das Text, Screenshot, Reihe, Diagramm enthält.&#10;&#10;KI-generierte Inhalte können fehlerhaft sein.">
-            <a:extLst>
-              <a:ext uri="{FF2B5EF4-FFF2-40B4-BE49-F238E27FC236}">
-                <a16:creationId xmlns:a16="http://schemas.microsoft.com/office/drawing/2014/main" id="{73587B8A-5104-99AB-5F59-EAFD5D5D47D6}"/>
+          <p:cNvPr id="13" name="Inhaltsplatzhalter 12" descr="Ein Bild, das Text, Reihe, Screenshot, Diagramm enthält.&#10;&#10;KI-generierte Inhalte können fehlerhaft sein.">
+            <a:extLst>
+              <a:ext uri="{FF2B5EF4-FFF2-40B4-BE49-F238E27FC236}">
+                <a16:creationId xmlns:a16="http://schemas.microsoft.com/office/drawing/2014/main" id="{7150BCB9-895A-DC8B-6221-F75DDCE16BA1}"/>
               </a:ext>
             </a:extLst>
           </p:cNvPr>
@@ -3890,177 +3898,8 @@
         </p:blipFill>
         <p:spPr>
           <a:xfrm>
-            <a:off x="839788" y="2527454"/>
-            <a:ext cx="7149180" cy="3639830"/>
-          </a:xfrm>
-        </p:spPr>
-      </p:pic>
-    </p:spTree>
-    <p:extLst>
-      <p:ext uri="{BB962C8B-B14F-4D97-AF65-F5344CB8AC3E}">
-        <p14:creationId xmlns:p14="http://schemas.microsoft.com/office/powerpoint/2010/main" val="2464344804"/>
-      </p:ext>
-    </p:extLst>
-  </p:cSld>
-  <p:clrMapOvr>
-    <a:masterClrMapping/>
-  </p:clrMapOvr>
-</p:sld>
-</file>
-
-<file path=ppt/slides/slide13.xml><?xml version="1.0" encoding="utf-8"?>
-<p:sld xmlns:a="http://schemas.openxmlformats.org/drawingml/2006/main" xmlns:r="http://schemas.openxmlformats.org/officeDocument/2006/relationships" xmlns:p="http://schemas.openxmlformats.org/presentationml/2006/main">
-  <p:cSld>
-    <p:spTree>
-      <p:nvGrpSpPr>
-        <p:cNvPr id="1" name=""/>
-        <p:cNvGrpSpPr/>
-        <p:nvPr/>
-      </p:nvGrpSpPr>
-      <p:grpSpPr>
-        <a:xfrm>
-          <a:off x="0" y="0"/>
-          <a:ext cx="0" cy="0"/>
-          <a:chOff x="0" y="0"/>
-          <a:chExt cx="0" cy="0"/>
-        </a:xfrm>
-      </p:grpSpPr>
-      <p:sp>
-        <p:nvSpPr>
-          <p:cNvPr id="2" name="Titel 1">
-            <a:extLst>
-              <a:ext uri="{FF2B5EF4-FFF2-40B4-BE49-F238E27FC236}">
-                <a16:creationId xmlns:a16="http://schemas.microsoft.com/office/drawing/2014/main" id="{830BF0CD-BE3D-9267-722D-D370E0B66748}"/>
-              </a:ext>
-            </a:extLst>
-          </p:cNvPr>
-          <p:cNvSpPr>
-            <a:spLocks noGrp="1"/>
-          </p:cNvSpPr>
-          <p:nvPr>
-            <p:ph type="title"/>
-          </p:nvPr>
-        </p:nvSpPr>
-        <p:spPr/>
-        <p:txBody>
-          <a:bodyPr/>
-          <a:lstStyle/>
-          <a:p>
-            <a:r>
-              <a:rPr lang="de-DE" dirty="0" err="1"/>
-              <a:t>Recommendation</a:t>
-            </a:r>
-            <a:endParaRPr lang="de-DE" dirty="0"/>
-          </a:p>
-        </p:txBody>
-      </p:sp>
-      <p:sp>
-        <p:nvSpPr>
-          <p:cNvPr id="3" name="Textplatzhalter 2">
-            <a:extLst>
-              <a:ext uri="{FF2B5EF4-FFF2-40B4-BE49-F238E27FC236}">
-                <a16:creationId xmlns:a16="http://schemas.microsoft.com/office/drawing/2014/main" id="{33A329DF-91F2-3B97-379D-11E548739052}"/>
-              </a:ext>
-            </a:extLst>
-          </p:cNvPr>
-          <p:cNvSpPr>
-            <a:spLocks noGrp="1"/>
-          </p:cNvSpPr>
-          <p:nvPr>
-            <p:ph type="body" idx="1"/>
-          </p:nvPr>
-        </p:nvSpPr>
-        <p:spPr>
-          <a:xfrm>
-            <a:off x="839788" y="1681163"/>
-            <a:ext cx="10512424" cy="823912"/>
-          </a:xfrm>
-        </p:spPr>
-        <p:txBody>
-          <a:bodyPr anchor="t">
-            <a:normAutofit/>
-          </a:bodyPr>
-          <a:lstStyle/>
-          <a:p>
-            <a:r>
-              <a:rPr lang="de-DE" dirty="0"/>
-              <a:t>Hypothesis 3: </a:t>
-            </a:r>
-            <a:r>
-              <a:rPr lang="en-US" dirty="0"/>
-              <a:t>The price for a house is lower in the first half of a year</a:t>
-            </a:r>
-          </a:p>
-        </p:txBody>
-      </p:sp>
-      <p:sp>
-        <p:nvSpPr>
-          <p:cNvPr id="6" name="Inhaltsplatzhalter 5">
-            <a:extLst>
-              <a:ext uri="{FF2B5EF4-FFF2-40B4-BE49-F238E27FC236}">
-                <a16:creationId xmlns:a16="http://schemas.microsoft.com/office/drawing/2014/main" id="{48AEF6D4-262B-FB9C-93F4-5628A4093C50}"/>
-              </a:ext>
-            </a:extLst>
-          </p:cNvPr>
-          <p:cNvSpPr>
-            <a:spLocks noGrp="1"/>
-          </p:cNvSpPr>
-          <p:nvPr>
-            <p:ph sz="quarter" idx="4"/>
-          </p:nvPr>
-        </p:nvSpPr>
-        <p:spPr>
-          <a:xfrm>
-            <a:off x="8582526" y="2505075"/>
-            <a:ext cx="2772862" cy="3684588"/>
-          </a:xfrm>
-        </p:spPr>
-        <p:txBody>
-          <a:bodyPr/>
-          <a:lstStyle/>
-          <a:p>
-            <a:r>
-              <a:rPr lang="en-US" sz="2400" b="1" dirty="0"/>
-              <a:t>98188 is the cheapest zip code in Seattle</a:t>
-            </a:r>
-          </a:p>
-          <a:p>
-            <a:endParaRPr lang="de-DE" dirty="0"/>
-          </a:p>
-        </p:txBody>
-      </p:sp>
-      <p:pic>
-        <p:nvPicPr>
-          <p:cNvPr id="8" name="Inhaltsplatzhalter 7" descr="Ein Bild, das Text, Screenshot, Diagramm, Reihe enthält.&#10;&#10;KI-generierte Inhalte können fehlerhaft sein.">
-            <a:extLst>
-              <a:ext uri="{FF2B5EF4-FFF2-40B4-BE49-F238E27FC236}">
-                <a16:creationId xmlns:a16="http://schemas.microsoft.com/office/drawing/2014/main" id="{683AFFA5-F636-7258-C540-067BC158D45E}"/>
-              </a:ext>
-            </a:extLst>
-          </p:cNvPr>
-          <p:cNvPicPr>
-            <a:picLocks noGrp="1" noChangeAspect="1"/>
-          </p:cNvPicPr>
-          <p:nvPr>
-            <p:ph sz="half" idx="2"/>
-          </p:nvPr>
-        </p:nvPicPr>
-        <p:blipFill>
-          <a:blip r:embed="rId2">
-            <a:extLst>
-              <a:ext uri="{28A0092B-C50C-407E-A947-70E740481C1C}">
-                <a14:useLocalDpi xmlns:a14="http://schemas.microsoft.com/office/drawing/2010/main" val="0"/>
-              </a:ext>
-            </a:extLst>
-          </a:blip>
-          <a:stretch>
-            <a:fillRect/>
-          </a:stretch>
-        </p:blipFill>
-        <p:spPr>
-          <a:xfrm>
-            <a:off x="839788" y="2510064"/>
-            <a:ext cx="7534191" cy="3674610"/>
+            <a:off x="836612" y="2308714"/>
+            <a:ext cx="7325643" cy="4088423"/>
           </a:xfrm>
         </p:spPr>
       </p:pic>
@@ -4077,7 +3916,7 @@
 </p:sld>
 </file>
 
-<file path=ppt/slides/slide14.xml><?xml version="1.0" encoding="utf-8"?>
+<file path=ppt/slides/slide13.xml><?xml version="1.0" encoding="utf-8"?>
 <p:sld xmlns:a="http://schemas.openxmlformats.org/drawingml/2006/main" xmlns:r="http://schemas.openxmlformats.org/officeDocument/2006/relationships" xmlns:p="http://schemas.openxmlformats.org/presentationml/2006/main">
   <p:cSld>
     <p:spTree>
@@ -5003,7 +4842,7 @@
           <p:cNvPr id="2" name="Titel 1">
             <a:extLst>
               <a:ext uri="{FF2B5EF4-FFF2-40B4-BE49-F238E27FC236}">
-                <a16:creationId xmlns:a16="http://schemas.microsoft.com/office/drawing/2014/main" id="{B52FF620-B3DA-35B8-9695-B568C2639024}"/>
+                <a16:creationId xmlns:a16="http://schemas.microsoft.com/office/drawing/2014/main" id="{7E82BCC7-0AB8-4CA6-C229-A19B93EEAA83}"/>
               </a:ext>
             </a:extLst>
           </p:cNvPr>
@@ -5017,6 +4856,44 @@
         <p:spPr/>
         <p:txBody>
           <a:bodyPr/>
+          <a:lstStyle/>
+          <a:p>
+            <a:r>
+              <a:rPr lang="de-DE" dirty="0"/>
+              <a:t>Data </a:t>
+            </a:r>
+            <a:r>
+              <a:rPr lang="de-DE" dirty="0" err="1"/>
+              <a:t>cleaning</a:t>
+            </a:r>
+            <a:endParaRPr lang="de-DE" dirty="0"/>
+          </a:p>
+        </p:txBody>
+      </p:sp>
+      <p:sp>
+        <p:nvSpPr>
+          <p:cNvPr id="3" name="Textplatzhalter 2">
+            <a:extLst>
+              <a:ext uri="{FF2B5EF4-FFF2-40B4-BE49-F238E27FC236}">
+                <a16:creationId xmlns:a16="http://schemas.microsoft.com/office/drawing/2014/main" id="{1BAA1631-52B1-E679-EB67-D0DCBF39A125}"/>
+              </a:ext>
+            </a:extLst>
+          </p:cNvPr>
+          <p:cNvSpPr>
+            <a:spLocks noGrp="1"/>
+          </p:cNvSpPr>
+          <p:nvPr>
+            <p:ph type="body" idx="1"/>
+          </p:nvPr>
+        </p:nvSpPr>
+        <p:spPr>
+          <a:xfrm>
+            <a:off x="884738" y="1452062"/>
+            <a:ext cx="10512424" cy="823912"/>
+          </a:xfrm>
+        </p:spPr>
+        <p:txBody>
+          <a:bodyPr anchor="t"/>
           <a:lstStyle/>
           <a:p>
             <a:r>
@@ -5072,10 +4949,10 @@
       </p:sp>
       <p:pic>
         <p:nvPicPr>
-          <p:cNvPr id="6" name="Inhaltsplatzhalter 5" descr="Ein Bild, das Karte, Text, Atlas enthält.&#10;&#10;KI-generierte Inhalte können fehlerhaft sein.">
-            <a:extLst>
-              <a:ext uri="{FF2B5EF4-FFF2-40B4-BE49-F238E27FC236}">
-                <a16:creationId xmlns:a16="http://schemas.microsoft.com/office/drawing/2014/main" id="{654A35F7-DFAE-9FD3-8C4C-CD9FEE1FAFFA}"/>
+          <p:cNvPr id="16" name="Inhaltsplatzhalter 15" descr="Ein Bild, das Karte, Text, Atlas enthält.&#10;&#10;KI-generierte Inhalte können fehlerhaft sein.">
+            <a:extLst>
+              <a:ext uri="{FF2B5EF4-FFF2-40B4-BE49-F238E27FC236}">
+                <a16:creationId xmlns:a16="http://schemas.microsoft.com/office/drawing/2014/main" id="{E0517977-1F6A-49B0-427C-5B5ADEC2419E}"/>
               </a:ext>
             </a:extLst>
           </p:cNvPr>
@@ -5083,7 +4960,7 @@
             <a:picLocks noGrp="1" noChangeAspect="1"/>
           </p:cNvPicPr>
           <p:nvPr>
-            <p:ph sz="half" idx="1"/>
+            <p:ph sz="half" idx="2"/>
           </p:nvPr>
         </p:nvPicPr>
         <p:blipFill>
@@ -5100,17 +4977,17 @@
         </p:blipFill>
         <p:spPr>
           <a:xfrm>
-            <a:off x="1140602" y="1825625"/>
-            <a:ext cx="4576796" cy="4351338"/>
+            <a:off x="994611" y="2133600"/>
+            <a:ext cx="4973052" cy="4056063"/>
           </a:xfrm>
         </p:spPr>
       </p:pic>
       <p:pic>
         <p:nvPicPr>
-          <p:cNvPr id="8" name="Inhaltsplatzhalter 7" descr="Ein Bild, das Karte, Text, Atlas enthält.&#10;&#10;KI-generierte Inhalte können fehlerhaft sein.">
-            <a:extLst>
-              <a:ext uri="{FF2B5EF4-FFF2-40B4-BE49-F238E27FC236}">
-                <a16:creationId xmlns:a16="http://schemas.microsoft.com/office/drawing/2014/main" id="{B744FEC6-754C-9551-977C-A169719A5950}"/>
+          <p:cNvPr id="18" name="Inhaltsplatzhalter 17" descr="Ein Bild, das Karte, Text, Atlas enthält.&#10;&#10;KI-generierte Inhalte können fehlerhaft sein.">
+            <a:extLst>
+              <a:ext uri="{FF2B5EF4-FFF2-40B4-BE49-F238E27FC236}">
+                <a16:creationId xmlns:a16="http://schemas.microsoft.com/office/drawing/2014/main" id="{7A496F8D-0048-13C9-59AC-C3C4E7EF5841}"/>
               </a:ext>
             </a:extLst>
           </p:cNvPr>
@@ -5118,7 +4995,7 @@
             <a:picLocks noGrp="1" noChangeAspect="1"/>
           </p:cNvPicPr>
           <p:nvPr>
-            <p:ph sz="half" idx="2"/>
+            <p:ph sz="quarter" idx="4"/>
           </p:nvPr>
         </p:nvPicPr>
         <p:blipFill>
@@ -5135,15 +5012,15 @@
         </p:blipFill>
         <p:spPr>
           <a:xfrm>
-            <a:off x="6474602" y="1825625"/>
-            <a:ext cx="4576796" cy="4351338"/>
+            <a:off x="6224337" y="2133600"/>
+            <a:ext cx="4973052" cy="4056063"/>
           </a:xfrm>
         </p:spPr>
       </p:pic>
     </p:spTree>
     <p:extLst>
       <p:ext uri="{BB962C8B-B14F-4D97-AF65-F5344CB8AC3E}">
-        <p14:creationId xmlns:p14="http://schemas.microsoft.com/office/powerpoint/2010/main" val="1772915654"/>
+        <p14:creationId xmlns:p14="http://schemas.microsoft.com/office/powerpoint/2010/main" val="2779389966"/>
       </p:ext>
     </p:extLst>
   </p:cSld>
@@ -5175,7 +5052,7 @@
           <p:cNvPr id="2" name="Titel 1">
             <a:extLst>
               <a:ext uri="{FF2B5EF4-FFF2-40B4-BE49-F238E27FC236}">
-                <a16:creationId xmlns:a16="http://schemas.microsoft.com/office/drawing/2014/main" id="{7E82BCC7-0AB8-4CA6-C229-A19B93EEAA83}"/>
+                <a16:creationId xmlns:a16="http://schemas.microsoft.com/office/drawing/2014/main" id="{7BB67729-EC38-1EF1-D658-D3D51E940F3E}"/>
               </a:ext>
             </a:extLst>
           </p:cNvPr>
@@ -5193,167 +5070,111 @@
           <a:p>
             <a:r>
               <a:rPr lang="de-DE" dirty="0"/>
-              <a:t>Data </a:t>
-            </a:r>
-            <a:r>
-              <a:rPr lang="de-DE" dirty="0" err="1"/>
-              <a:t>cleaning</a:t>
-            </a:r>
-            <a:endParaRPr lang="de-DE" dirty="0"/>
-          </a:p>
-        </p:txBody>
-      </p:sp>
-      <p:sp>
-        <p:nvSpPr>
-          <p:cNvPr id="3" name="Textplatzhalter 2">
-            <a:extLst>
-              <a:ext uri="{FF2B5EF4-FFF2-40B4-BE49-F238E27FC236}">
-                <a16:creationId xmlns:a16="http://schemas.microsoft.com/office/drawing/2014/main" id="{1BAA1631-52B1-E679-EB67-D0DCBF39A125}"/>
-              </a:ext>
-            </a:extLst>
-          </p:cNvPr>
-          <p:cNvSpPr>
-            <a:spLocks noGrp="1"/>
-          </p:cNvSpPr>
-          <p:nvPr>
-            <p:ph type="body" idx="1"/>
+              <a:t>Hypothesis</a:t>
+            </a:r>
+          </a:p>
+        </p:txBody>
+      </p:sp>
+      <p:sp>
+        <p:nvSpPr>
+          <p:cNvPr id="3" name="Inhaltsplatzhalter 2">
+            <a:extLst>
+              <a:ext uri="{FF2B5EF4-FFF2-40B4-BE49-F238E27FC236}">
+                <a16:creationId xmlns:a16="http://schemas.microsoft.com/office/drawing/2014/main" id="{551E1F0A-64B5-D676-183D-FE6F20FDC532}"/>
+              </a:ext>
+            </a:extLst>
+          </p:cNvPr>
+          <p:cNvSpPr>
+            <a:spLocks noGrp="1"/>
+          </p:cNvSpPr>
+          <p:nvPr>
+            <p:ph idx="1"/>
           </p:nvPr>
         </p:nvSpPr>
         <p:spPr>
           <a:xfrm>
-            <a:off x="884738" y="1452062"/>
-            <a:ext cx="10512424" cy="823912"/>
+            <a:off x="838200" y="1690688"/>
+            <a:ext cx="10515600" cy="4486275"/>
           </a:xfrm>
         </p:spPr>
         <p:txBody>
-          <a:bodyPr anchor="t"/>
-          <a:lstStyle/>
-          <a:p>
-            <a:r>
-              <a:rPr lang="de-DE" dirty="0" err="1"/>
-              <a:t>Filtering</a:t>
-            </a:r>
-            <a:r>
-              <a:rPr lang="de-DE" dirty="0"/>
-              <a:t> </a:t>
-            </a:r>
-            <a:r>
-              <a:rPr lang="de-DE" dirty="0" err="1"/>
-              <a:t>the</a:t>
-            </a:r>
-            <a:r>
-              <a:rPr lang="de-DE" dirty="0"/>
-              <a:t> </a:t>
-            </a:r>
-            <a:r>
-              <a:rPr lang="de-DE" dirty="0" err="1"/>
-              <a:t>central</a:t>
-            </a:r>
-            <a:r>
-              <a:rPr lang="de-DE" dirty="0"/>
-              <a:t> </a:t>
-            </a:r>
-            <a:r>
-              <a:rPr lang="de-DE" dirty="0" err="1"/>
-              <a:t>neighborhood</a:t>
-            </a:r>
-            <a:r>
-              <a:rPr lang="de-DE" dirty="0"/>
-              <a:t> </a:t>
-            </a:r>
-            <a:r>
-              <a:rPr lang="de-DE" dirty="0" err="1"/>
-              <a:t>by</a:t>
-            </a:r>
-            <a:r>
-              <a:rPr lang="de-DE" dirty="0"/>
-              <a:t> </a:t>
-            </a:r>
-            <a:r>
-              <a:rPr lang="de-DE" dirty="0" err="1"/>
-              <a:t>zip</a:t>
-            </a:r>
-            <a:r>
-              <a:rPr lang="de-DE" dirty="0"/>
-              <a:t> code</a:t>
-            </a:r>
-          </a:p>
-        </p:txBody>
-      </p:sp>
-      <p:pic>
-        <p:nvPicPr>
-          <p:cNvPr id="16" name="Inhaltsplatzhalter 15" descr="Ein Bild, das Karte, Text, Atlas enthält.&#10;&#10;KI-generierte Inhalte können fehlerhaft sein.">
-            <a:extLst>
-              <a:ext uri="{FF2B5EF4-FFF2-40B4-BE49-F238E27FC236}">
-                <a16:creationId xmlns:a16="http://schemas.microsoft.com/office/drawing/2014/main" id="{E0517977-1F6A-49B0-427C-5B5ADEC2419E}"/>
-              </a:ext>
-            </a:extLst>
-          </p:cNvPr>
-          <p:cNvPicPr>
-            <a:picLocks noGrp="1" noChangeAspect="1"/>
-          </p:cNvPicPr>
-          <p:nvPr>
-            <p:ph sz="half" idx="2"/>
-          </p:nvPr>
-        </p:nvPicPr>
-        <p:blipFill>
-          <a:blip r:embed="rId2">
-            <a:extLst>
-              <a:ext uri="{28A0092B-C50C-407E-A947-70E740481C1C}">
-                <a14:useLocalDpi xmlns:a14="http://schemas.microsoft.com/office/drawing/2010/main" val="0"/>
-              </a:ext>
-            </a:extLst>
-          </a:blip>
-          <a:stretch>
-            <a:fillRect/>
-          </a:stretch>
-        </p:blipFill>
-        <p:spPr>
-          <a:xfrm>
-            <a:off x="994611" y="2133600"/>
-            <a:ext cx="4973052" cy="4056063"/>
-          </a:xfrm>
-        </p:spPr>
-      </p:pic>
-      <p:pic>
-        <p:nvPicPr>
-          <p:cNvPr id="18" name="Inhaltsplatzhalter 17" descr="Ein Bild, das Karte, Text, Atlas enthält.&#10;&#10;KI-generierte Inhalte können fehlerhaft sein.">
-            <a:extLst>
-              <a:ext uri="{FF2B5EF4-FFF2-40B4-BE49-F238E27FC236}">
-                <a16:creationId xmlns:a16="http://schemas.microsoft.com/office/drawing/2014/main" id="{7A496F8D-0048-13C9-59AC-C3C4E7EF5841}"/>
-              </a:ext>
-            </a:extLst>
-          </p:cNvPr>
-          <p:cNvPicPr>
-            <a:picLocks noGrp="1" noChangeAspect="1"/>
-          </p:cNvPicPr>
-          <p:nvPr>
-            <p:ph sz="quarter" idx="4"/>
-          </p:nvPr>
-        </p:nvPicPr>
-        <p:blipFill>
-          <a:blip r:embed="rId3">
-            <a:extLst>
-              <a:ext uri="{28A0092B-C50C-407E-A947-70E740481C1C}">
-                <a14:useLocalDpi xmlns:a14="http://schemas.microsoft.com/office/drawing/2010/main" val="0"/>
-              </a:ext>
-            </a:extLst>
-          </a:blip>
-          <a:stretch>
-            <a:fillRect/>
-          </a:stretch>
-        </p:blipFill>
-        <p:spPr>
-          <a:xfrm>
-            <a:off x="6224337" y="2133600"/>
-            <a:ext cx="4973052" cy="4056063"/>
-          </a:xfrm>
-        </p:spPr>
-      </p:pic>
+          <a:bodyPr>
+            <a:normAutofit lnSpcReduction="10000"/>
+          </a:bodyPr>
+          <a:lstStyle/>
+          <a:p>
+            <a:pPr marL="0" indent="0">
+              <a:buNone/>
+            </a:pPr>
+            <a:r>
+              <a:rPr lang="de-DE" dirty="0"/>
+              <a:t>Hypothesis 1:</a:t>
+            </a:r>
+          </a:p>
+          <a:p>
+            <a:pPr marL="0" indent="0">
+              <a:buNone/>
+            </a:pPr>
+            <a:r>
+              <a:rPr lang="en-US" dirty="0"/>
+              <a:t>The more square feet and/or square lot the location has the higher the price.</a:t>
+            </a:r>
+          </a:p>
+          <a:p>
+            <a:pPr marL="0" indent="0">
+              <a:buNone/>
+            </a:pPr>
+            <a:endParaRPr lang="en-US" dirty="0"/>
+          </a:p>
+          <a:p>
+            <a:pPr marL="0" indent="0">
+              <a:buNone/>
+            </a:pPr>
+            <a:r>
+              <a:rPr lang="en-US" dirty="0"/>
+              <a:t>Hypothesis 2: </a:t>
+            </a:r>
+          </a:p>
+          <a:p>
+            <a:pPr marL="0" indent="0">
+              <a:buNone/>
+            </a:pPr>
+            <a:r>
+              <a:rPr lang="en-US" dirty="0"/>
+              <a:t>There is at least one variable which has a bigger impact on the price than the others.</a:t>
+            </a:r>
+          </a:p>
+          <a:p>
+            <a:pPr marL="0" indent="0">
+              <a:buNone/>
+            </a:pPr>
+            <a:endParaRPr lang="de-DE" dirty="0"/>
+          </a:p>
+          <a:p>
+            <a:pPr marL="0" indent="0">
+              <a:buNone/>
+            </a:pPr>
+            <a:r>
+              <a:rPr lang="de-DE" dirty="0"/>
+              <a:t>Hypothesis 3:</a:t>
+            </a:r>
+          </a:p>
+          <a:p>
+            <a:pPr marL="0" indent="0">
+              <a:buNone/>
+            </a:pPr>
+            <a:r>
+              <a:rPr lang="en-US" dirty="0"/>
+              <a:t>The price for a house is lower in the first half of a year.</a:t>
+            </a:r>
+            <a:endParaRPr lang="de-DE" dirty="0"/>
+          </a:p>
+        </p:txBody>
+      </p:sp>
     </p:spTree>
     <p:extLst>
       <p:ext uri="{BB962C8B-B14F-4D97-AF65-F5344CB8AC3E}">
-        <p14:creationId xmlns:p14="http://schemas.microsoft.com/office/powerpoint/2010/main" val="2779389966"/>
+        <p14:creationId xmlns:p14="http://schemas.microsoft.com/office/powerpoint/2010/main" val="2583013064"/>
       </p:ext>
     </p:extLst>
   </p:cSld>
@@ -5385,7 +5206,7 @@
           <p:cNvPr id="2" name="Titel 1">
             <a:extLst>
               <a:ext uri="{FF2B5EF4-FFF2-40B4-BE49-F238E27FC236}">
-                <a16:creationId xmlns:a16="http://schemas.microsoft.com/office/drawing/2014/main" id="{7BB67729-EC38-1EF1-D658-D3D51E940F3E}"/>
+                <a16:creationId xmlns:a16="http://schemas.microsoft.com/office/drawing/2014/main" id="{830BF0CD-BE3D-9267-722D-D370E0B66748}"/>
               </a:ext>
             </a:extLst>
           </p:cNvPr>
@@ -5410,104 +5231,110 @@
       </p:sp>
       <p:sp>
         <p:nvSpPr>
-          <p:cNvPr id="3" name="Inhaltsplatzhalter 2">
-            <a:extLst>
-              <a:ext uri="{FF2B5EF4-FFF2-40B4-BE49-F238E27FC236}">
-                <a16:creationId xmlns:a16="http://schemas.microsoft.com/office/drawing/2014/main" id="{551E1F0A-64B5-D676-183D-FE6F20FDC532}"/>
-              </a:ext>
-            </a:extLst>
-          </p:cNvPr>
-          <p:cNvSpPr>
-            <a:spLocks noGrp="1"/>
-          </p:cNvSpPr>
-          <p:nvPr>
-            <p:ph idx="1"/>
+          <p:cNvPr id="3" name="Textplatzhalter 2">
+            <a:extLst>
+              <a:ext uri="{FF2B5EF4-FFF2-40B4-BE49-F238E27FC236}">
+                <a16:creationId xmlns:a16="http://schemas.microsoft.com/office/drawing/2014/main" id="{33A329DF-91F2-3B97-379D-11E548739052}"/>
+              </a:ext>
+            </a:extLst>
+          </p:cNvPr>
+          <p:cNvSpPr>
+            <a:spLocks noGrp="1"/>
+          </p:cNvSpPr>
+          <p:nvPr>
+            <p:ph type="body" idx="1"/>
           </p:nvPr>
         </p:nvSpPr>
         <p:spPr>
           <a:xfrm>
-            <a:off x="838200" y="1690688"/>
-            <a:ext cx="10515600" cy="4486275"/>
+            <a:off x="839788" y="1681163"/>
+            <a:ext cx="10512424" cy="823912"/>
           </a:xfrm>
         </p:spPr>
         <p:txBody>
-          <a:bodyPr>
-            <a:normAutofit lnSpcReduction="10000"/>
-          </a:bodyPr>
-          <a:lstStyle/>
-          <a:p>
-            <a:pPr marL="0" indent="0">
-              <a:buNone/>
-            </a:pPr>
-            <a:r>
-              <a:rPr lang="de-DE" dirty="0"/>
-              <a:t>Hypothesis 1:</a:t>
-            </a:r>
-          </a:p>
-          <a:p>
-            <a:pPr marL="0" indent="0">
-              <a:buNone/>
-            </a:pPr>
+          <a:bodyPr/>
+          <a:lstStyle/>
+          <a:p>
+            <a:r>
+              <a:rPr lang="de-DE" dirty="0"/>
+              <a:t>Hypothesis 1: </a:t>
+            </a:r>
             <a:r>
               <a:rPr lang="en-US" dirty="0"/>
               <a:t>The more square feet and/or square lot the location has the higher the price.</a:t>
             </a:r>
           </a:p>
-          <a:p>
-            <a:pPr marL="0" indent="0">
-              <a:buNone/>
-            </a:pPr>
-            <a:endParaRPr lang="en-US" dirty="0"/>
-          </a:p>
-          <a:p>
-            <a:pPr marL="0" indent="0">
-              <a:buNone/>
-            </a:pPr>
-            <a:r>
-              <a:rPr lang="en-US" dirty="0"/>
-              <a:t>Hypothesis 2: </a:t>
-            </a:r>
-          </a:p>
-          <a:p>
-            <a:pPr marL="0" indent="0">
-              <a:buNone/>
-            </a:pPr>
-            <a:r>
-              <a:rPr lang="en-US" dirty="0"/>
-              <a:t>There is at least one variable which has a bigger impact on the price than the others.</a:t>
-            </a:r>
-          </a:p>
-          <a:p>
-            <a:pPr marL="0" indent="0">
-              <a:buNone/>
-            </a:pPr>
+        </p:txBody>
+      </p:sp>
+      <p:sp>
+        <p:nvSpPr>
+          <p:cNvPr id="6" name="Inhaltsplatzhalter 5">
+            <a:extLst>
+              <a:ext uri="{FF2B5EF4-FFF2-40B4-BE49-F238E27FC236}">
+                <a16:creationId xmlns:a16="http://schemas.microsoft.com/office/drawing/2014/main" id="{48AEF6D4-262B-FB9C-93F4-5628A4093C50}"/>
+              </a:ext>
+            </a:extLst>
+          </p:cNvPr>
+          <p:cNvSpPr>
+            <a:spLocks noGrp="1"/>
+          </p:cNvSpPr>
+          <p:nvPr>
+            <p:ph sz="quarter" idx="4"/>
+          </p:nvPr>
+        </p:nvSpPr>
+        <p:spPr>
+          <a:xfrm>
+            <a:off x="8582526" y="2505075"/>
+            <a:ext cx="2772862" cy="3684588"/>
+          </a:xfrm>
+        </p:spPr>
+        <p:txBody>
+          <a:bodyPr/>
+          <a:lstStyle/>
+          <a:p>
             <a:endParaRPr lang="de-DE" dirty="0"/>
           </a:p>
-          <a:p>
-            <a:pPr marL="0" indent="0">
-              <a:buNone/>
-            </a:pPr>
-            <a:r>
-              <a:rPr lang="de-DE" dirty="0"/>
-              <a:t>Hypothesis 3:</a:t>
-            </a:r>
-          </a:p>
-          <a:p>
-            <a:pPr marL="0" indent="0">
-              <a:buNone/>
-            </a:pPr>
-            <a:r>
-              <a:rPr lang="en-US" dirty="0"/>
-              <a:t>The price for a house is lower in the first half of a year.</a:t>
-            </a:r>
-            <a:endParaRPr lang="de-DE" dirty="0"/>
-          </a:p>
-        </p:txBody>
-      </p:sp>
+        </p:txBody>
+      </p:sp>
+      <p:pic>
+        <p:nvPicPr>
+          <p:cNvPr id="12" name="Inhaltsplatzhalter 11" descr="Ein Bild, das Text, Screenshot, Reihe, parallel enthält.&#10;&#10;KI-generierte Inhalte können fehlerhaft sein.">
+            <a:extLst>
+              <a:ext uri="{FF2B5EF4-FFF2-40B4-BE49-F238E27FC236}">
+                <a16:creationId xmlns:a16="http://schemas.microsoft.com/office/drawing/2014/main" id="{4719EDD3-A076-BFB4-D712-9B802C62EDB2}"/>
+              </a:ext>
+            </a:extLst>
+          </p:cNvPr>
+          <p:cNvPicPr>
+            <a:picLocks noGrp="1" noChangeAspect="1"/>
+          </p:cNvPicPr>
+          <p:nvPr>
+            <p:ph sz="half" idx="2"/>
+          </p:nvPr>
+        </p:nvPicPr>
+        <p:blipFill>
+          <a:blip r:embed="rId2">
+            <a:extLst>
+              <a:ext uri="{28A0092B-C50C-407E-A947-70E740481C1C}">
+                <a14:useLocalDpi xmlns:a14="http://schemas.microsoft.com/office/drawing/2010/main" val="0"/>
+              </a:ext>
+            </a:extLst>
+          </a:blip>
+          <a:stretch>
+            <a:fillRect/>
+          </a:stretch>
+        </p:blipFill>
+        <p:spPr>
+          <a:xfrm>
+            <a:off x="839788" y="2505075"/>
+            <a:ext cx="7453980" cy="3684587"/>
+          </a:xfrm>
+        </p:spPr>
+      </p:pic>
     </p:spTree>
     <p:extLst>
       <p:ext uri="{BB962C8B-B14F-4D97-AF65-F5344CB8AC3E}">
-        <p14:creationId xmlns:p14="http://schemas.microsoft.com/office/powerpoint/2010/main" val="2583013064"/>
+        <p14:creationId xmlns:p14="http://schemas.microsoft.com/office/powerpoint/2010/main" val="2348754011"/>
       </p:ext>
     </p:extLst>
   </p:cSld>
@@ -5599,12 +5426,42 @@
           </a:p>
         </p:txBody>
       </p:sp>
+      <p:sp>
+        <p:nvSpPr>
+          <p:cNvPr id="6" name="Inhaltsplatzhalter 5">
+            <a:extLst>
+              <a:ext uri="{FF2B5EF4-FFF2-40B4-BE49-F238E27FC236}">
+                <a16:creationId xmlns:a16="http://schemas.microsoft.com/office/drawing/2014/main" id="{48AEF6D4-262B-FB9C-93F4-5628A4093C50}"/>
+              </a:ext>
+            </a:extLst>
+          </p:cNvPr>
+          <p:cNvSpPr>
+            <a:spLocks noGrp="1"/>
+          </p:cNvSpPr>
+          <p:nvPr>
+            <p:ph sz="quarter" idx="4"/>
+          </p:nvPr>
+        </p:nvSpPr>
+        <p:spPr>
+          <a:xfrm>
+            <a:off x="8582526" y="2505075"/>
+            <a:ext cx="2772862" cy="3684588"/>
+          </a:xfrm>
+        </p:spPr>
+        <p:txBody>
+          <a:bodyPr/>
+          <a:lstStyle/>
+          <a:p>
+            <a:endParaRPr lang="de-DE" dirty="0"/>
+          </a:p>
+        </p:txBody>
+      </p:sp>
       <p:pic>
         <p:nvPicPr>
-          <p:cNvPr id="8" name="Inhaltsplatzhalter 7" descr="Ein Bild, das Text, Screenshot, Diagramm, Reihe enthält.&#10;&#10;KI-generierte Inhalte können fehlerhaft sein.">
-            <a:extLst>
-              <a:ext uri="{FF2B5EF4-FFF2-40B4-BE49-F238E27FC236}">
-                <a16:creationId xmlns:a16="http://schemas.microsoft.com/office/drawing/2014/main" id="{7FF59A0F-3CAE-53E5-EB73-B6C986402FA6}"/>
+          <p:cNvPr id="13" name="Inhaltsplatzhalter 12" descr="Ein Bild, das Text, Screenshot, Diagramm, parallel enthält.&#10;&#10;KI-generierte Inhalte können fehlerhaft sein.">
+            <a:extLst>
+              <a:ext uri="{FF2B5EF4-FFF2-40B4-BE49-F238E27FC236}">
+                <a16:creationId xmlns:a16="http://schemas.microsoft.com/office/drawing/2014/main" id="{624D35B9-798E-56CD-BD14-C3B66A8621A5}"/>
               </a:ext>
             </a:extLst>
           </p:cNvPr>
@@ -5629,45 +5486,15 @@
         </p:blipFill>
         <p:spPr>
           <a:xfrm>
-            <a:off x="836612" y="2505075"/>
-            <a:ext cx="7441114" cy="3684588"/>
+            <a:off x="839788" y="2505075"/>
+            <a:ext cx="7470023" cy="3684588"/>
           </a:xfrm>
         </p:spPr>
       </p:pic>
-      <p:sp>
-        <p:nvSpPr>
-          <p:cNvPr id="6" name="Inhaltsplatzhalter 5">
-            <a:extLst>
-              <a:ext uri="{FF2B5EF4-FFF2-40B4-BE49-F238E27FC236}">
-                <a16:creationId xmlns:a16="http://schemas.microsoft.com/office/drawing/2014/main" id="{48AEF6D4-262B-FB9C-93F4-5628A4093C50}"/>
-              </a:ext>
-            </a:extLst>
-          </p:cNvPr>
-          <p:cNvSpPr>
-            <a:spLocks noGrp="1"/>
-          </p:cNvSpPr>
-          <p:nvPr>
-            <p:ph sz="quarter" idx="4"/>
-          </p:nvPr>
-        </p:nvSpPr>
-        <p:spPr>
-          <a:xfrm>
-            <a:off x="8582526" y="2505075"/>
-            <a:ext cx="2772862" cy="3684588"/>
-          </a:xfrm>
-        </p:spPr>
-        <p:txBody>
-          <a:bodyPr/>
-          <a:lstStyle/>
-          <a:p>
-            <a:endParaRPr lang="de-DE" dirty="0"/>
-          </a:p>
-        </p:txBody>
-      </p:sp>
     </p:spTree>
     <p:extLst>
       <p:ext uri="{BB962C8B-B14F-4D97-AF65-F5344CB8AC3E}">
-        <p14:creationId xmlns:p14="http://schemas.microsoft.com/office/powerpoint/2010/main" val="2348754011"/>
+        <p14:creationId xmlns:p14="http://schemas.microsoft.com/office/powerpoint/2010/main" val="2091510753"/>
       </p:ext>
     </p:extLst>
   </p:cSld>
@@ -5750,11 +5577,11 @@
           <a:p>
             <a:r>
               <a:rPr lang="de-DE" dirty="0"/>
-              <a:t>Hypothesis 1: </a:t>
+              <a:t>Hypothesis 2: </a:t>
             </a:r>
             <a:r>
               <a:rPr lang="en-US" dirty="0"/>
-              <a:t>The more square feet and/or square lot the location has the higher the price.</a:t>
+              <a:t>There is at least one variable which has a bigger impact on the price than the others.</a:t>
             </a:r>
           </a:p>
         </p:txBody>
@@ -5777,7 +5604,7 @@
         </p:nvSpPr>
         <p:spPr>
           <a:xfrm>
-            <a:off x="8582526" y="2505075"/>
+            <a:off x="8005010" y="2716128"/>
             <a:ext cx="2772862" cy="3684588"/>
           </a:xfrm>
         </p:spPr>
@@ -5791,10 +5618,10 @@
       </p:sp>
       <p:pic>
         <p:nvPicPr>
-          <p:cNvPr id="9" name="Inhaltsplatzhalter 8" descr="Ein Bild, das Text, Screenshot, Diagramm, parallel enthält.&#10;&#10;KI-generierte Inhalte können fehlerhaft sein.">
-            <a:extLst>
-              <a:ext uri="{FF2B5EF4-FFF2-40B4-BE49-F238E27FC236}">
-                <a16:creationId xmlns:a16="http://schemas.microsoft.com/office/drawing/2014/main" id="{06E51AC4-3202-62A3-C775-624FD75BB8E4}"/>
+          <p:cNvPr id="13" name="Inhaltsplatzhalter 12" descr="Ein Bild, das Screenshot, Muster, Quadrat, Rechteck enthält.&#10;&#10;KI-generierte Inhalte können fehlerhaft sein.">
+            <a:extLst>
+              <a:ext uri="{FF2B5EF4-FFF2-40B4-BE49-F238E27FC236}">
+                <a16:creationId xmlns:a16="http://schemas.microsoft.com/office/drawing/2014/main" id="{8FF14A41-3020-B49E-C1FD-A1D0D7F7D7FC}"/>
               </a:ext>
             </a:extLst>
           </p:cNvPr>
@@ -5819,15 +5646,15 @@
         </p:blipFill>
         <p:spPr>
           <a:xfrm>
-            <a:off x="871805" y="2505075"/>
-            <a:ext cx="7421963" cy="3684588"/>
+            <a:off x="807703" y="2617369"/>
+            <a:ext cx="6250823" cy="3805203"/>
           </a:xfrm>
         </p:spPr>
       </p:pic>
     </p:spTree>
     <p:extLst>
       <p:ext uri="{BB962C8B-B14F-4D97-AF65-F5344CB8AC3E}">
-        <p14:creationId xmlns:p14="http://schemas.microsoft.com/office/powerpoint/2010/main" val="2091510753"/>
+        <p14:creationId xmlns:p14="http://schemas.microsoft.com/office/powerpoint/2010/main" val="327037832"/>
       </p:ext>
     </p:extLst>
   </p:cSld>

</xml_diff>